<commit_message>
FInal Update for this semester
</commit_message>
<xml_diff>
--- a/Presentation/Hotel Management System.pptx
+++ b/Presentation/Hotel Management System.pptx
@@ -114,6 +114,11 @@
       </a:defRPr>
     </a:lvl9pPr>
   </p:defaultTextStyle>
+  <p:extLst>
+    <p:ext uri="{EFAFB233-063F-42B5-8137-9DF3F51BA10A}">
+      <p15:sldGuideLst xmlns:p15="http://schemas.microsoft.com/office/powerpoint/2012/main"/>
+    </p:ext>
+  </p:extLst>
 </p:presentation>
 </file>
 
@@ -303,7 +308,7 @@
           <a:p>
             <a:fld id="{4C395A61-FADD-4155-860F-FF7AD120FEEA}" type="datetimeFigureOut">
               <a:rPr lang="en-US" smtClean="0"/>
-              <a:t>4/30/2026</a:t>
+              <a:t>5/7/2026</a:t>
             </a:fld>
             <a:endParaRPr lang="en-US"/>
           </a:p>
@@ -578,7 +583,7 @@
           <a:p>
             <a:fld id="{4C395A61-FADD-4155-860F-FF7AD120FEEA}" type="datetimeFigureOut">
               <a:rPr lang="en-US" smtClean="0"/>
-              <a:t>4/30/2026</a:t>
+              <a:t>5/7/2026</a:t>
             </a:fld>
             <a:endParaRPr lang="en-US"/>
           </a:p>
@@ -772,7 +777,7 @@
           <a:p>
             <a:fld id="{4C395A61-FADD-4155-860F-FF7AD120FEEA}" type="datetimeFigureOut">
               <a:rPr lang="en-US" smtClean="0"/>
-              <a:t>4/30/2026</a:t>
+              <a:t>5/7/2026</a:t>
             </a:fld>
             <a:endParaRPr lang="en-US"/>
           </a:p>
@@ -1045,7 +1050,7 @@
           <a:p>
             <a:fld id="{4C395A61-FADD-4155-860F-FF7AD120FEEA}" type="datetimeFigureOut">
               <a:rPr lang="en-US" smtClean="0"/>
-              <a:t>4/30/2026</a:t>
+              <a:t>5/7/2026</a:t>
             </a:fld>
             <a:endParaRPr lang="en-US"/>
           </a:p>
@@ -1386,7 +1391,7 @@
           <a:p>
             <a:fld id="{4C395A61-FADD-4155-860F-FF7AD120FEEA}" type="datetimeFigureOut">
               <a:rPr lang="en-US" smtClean="0"/>
-              <a:t>4/30/2026</a:t>
+              <a:t>5/7/2026</a:t>
             </a:fld>
             <a:endParaRPr lang="en-US"/>
           </a:p>
@@ -2009,7 +2014,7 @@
           <a:p>
             <a:fld id="{4C395A61-FADD-4155-860F-FF7AD120FEEA}" type="datetimeFigureOut">
               <a:rPr lang="en-US" smtClean="0"/>
-              <a:t>4/30/2026</a:t>
+              <a:t>5/7/2026</a:t>
             </a:fld>
             <a:endParaRPr lang="en-US"/>
           </a:p>
@@ -2869,7 +2874,7 @@
           <a:p>
             <a:fld id="{4C395A61-FADD-4155-860F-FF7AD120FEEA}" type="datetimeFigureOut">
               <a:rPr lang="en-US" smtClean="0"/>
-              <a:t>4/30/2026</a:t>
+              <a:t>5/7/2026</a:t>
             </a:fld>
             <a:endParaRPr lang="en-US"/>
           </a:p>
@@ -3039,7 +3044,7 @@
           <a:p>
             <a:fld id="{4C395A61-FADD-4155-860F-FF7AD120FEEA}" type="datetimeFigureOut">
               <a:rPr lang="en-US" smtClean="0"/>
-              <a:t>4/30/2026</a:t>
+              <a:t>5/7/2026</a:t>
             </a:fld>
             <a:endParaRPr lang="en-US"/>
           </a:p>
@@ -3219,7 +3224,7 @@
           <a:p>
             <a:fld id="{4C395A61-FADD-4155-860F-FF7AD120FEEA}" type="datetimeFigureOut">
               <a:rPr lang="en-US" smtClean="0"/>
-              <a:t>4/30/2026</a:t>
+              <a:t>5/7/2026</a:t>
             </a:fld>
             <a:endParaRPr lang="en-US"/>
           </a:p>
@@ -3389,7 +3394,7 @@
           <a:p>
             <a:fld id="{4C395A61-FADD-4155-860F-FF7AD120FEEA}" type="datetimeFigureOut">
               <a:rPr lang="en-US" smtClean="0"/>
-              <a:t>4/30/2026</a:t>
+              <a:t>5/7/2026</a:t>
             </a:fld>
             <a:endParaRPr lang="en-US"/>
           </a:p>
@@ -3636,7 +3641,7 @@
           <a:p>
             <a:fld id="{4C395A61-FADD-4155-860F-FF7AD120FEEA}" type="datetimeFigureOut">
               <a:rPr lang="en-US" smtClean="0"/>
-              <a:t>4/30/2026</a:t>
+              <a:t>5/7/2026</a:t>
             </a:fld>
             <a:endParaRPr lang="en-US"/>
           </a:p>
@@ -3928,7 +3933,7 @@
           <a:p>
             <a:fld id="{4C395A61-FADD-4155-860F-FF7AD120FEEA}" type="datetimeFigureOut">
               <a:rPr lang="en-US" smtClean="0"/>
-              <a:t>4/30/2026</a:t>
+              <a:t>5/7/2026</a:t>
             </a:fld>
             <a:endParaRPr lang="en-US"/>
           </a:p>
@@ -4372,7 +4377,7 @@
           <a:p>
             <a:fld id="{4C395A61-FADD-4155-860F-FF7AD120FEEA}" type="datetimeFigureOut">
               <a:rPr lang="en-US" smtClean="0"/>
-              <a:t>4/30/2026</a:t>
+              <a:t>5/7/2026</a:t>
             </a:fld>
             <a:endParaRPr lang="en-US"/>
           </a:p>
@@ -4490,7 +4495,7 @@
           <a:p>
             <a:fld id="{4C395A61-FADD-4155-860F-FF7AD120FEEA}" type="datetimeFigureOut">
               <a:rPr lang="en-US" smtClean="0"/>
-              <a:t>4/30/2026</a:t>
+              <a:t>5/7/2026</a:t>
             </a:fld>
             <a:endParaRPr lang="en-US"/>
           </a:p>
@@ -4585,7 +4590,7 @@
           <a:p>
             <a:fld id="{4C395A61-FADD-4155-860F-FF7AD120FEEA}" type="datetimeFigureOut">
               <a:rPr lang="en-US" smtClean="0"/>
-              <a:t>4/30/2026</a:t>
+              <a:t>5/7/2026</a:t>
             </a:fld>
             <a:endParaRPr lang="en-US"/>
           </a:p>
@@ -4864,7 +4869,7 @@
           <a:p>
             <a:fld id="{4C395A61-FADD-4155-860F-FF7AD120FEEA}" type="datetimeFigureOut">
               <a:rPr lang="en-US" smtClean="0"/>
-              <a:t>4/30/2026</a:t>
+              <a:t>5/7/2026</a:t>
             </a:fld>
             <a:endParaRPr lang="en-US"/>
           </a:p>
@@ -5139,7 +5144,7 @@
           <a:p>
             <a:fld id="{4C395A61-FADD-4155-860F-FF7AD120FEEA}" type="datetimeFigureOut">
               <a:rPr lang="en-US" smtClean="0"/>
-              <a:t>4/30/2026</a:t>
+              <a:t>5/7/2026</a:t>
             </a:fld>
             <a:endParaRPr lang="en-US"/>
           </a:p>
@@ -5342,6 +5347,13 @@
             <a:schemeClr val="lt1"/>
           </a:fontRef>
         </p:style>
+        <p:txBody>
+          <a:bodyPr/>
+          <a:lstStyle/>
+          <a:p>
+            <a:endParaRPr lang="en-US"/>
+          </a:p>
+        </p:txBody>
       </p:sp>
       <p:pic>
         <p:nvPicPr>
@@ -5436,6 +5448,13 @@
             <a:schemeClr val="lt1"/>
           </a:fontRef>
         </p:style>
+        <p:txBody>
+          <a:bodyPr/>
+          <a:lstStyle/>
+          <a:p>
+            <a:endParaRPr lang="en-US"/>
+          </a:p>
+        </p:txBody>
       </p:sp>
       <p:sp>
         <p:nvSpPr>
@@ -5568,7 +5587,7 @@
           <a:p>
             <a:fld id="{4C395A61-FADD-4155-860F-FF7AD120FEEA}" type="datetimeFigureOut">
               <a:rPr lang="en-US" smtClean="0"/>
-              <a:t>4/30/2026</a:t>
+              <a:t>5/7/2026</a:t>
             </a:fld>
             <a:endParaRPr lang="en-US"/>
           </a:p>
@@ -10575,7 +10594,7 @@
         </p:blipFill>
         <p:spPr>
           <a:xfrm>
-            <a:off x="7563742" y="874925"/>
+            <a:off x="7833144" y="4019521"/>
             <a:ext cx="3980139" cy="2228878"/>
           </a:xfrm>
           <a:prstGeom prst="rect">
@@ -10959,7 +10978,7 @@
         </p:blipFill>
         <p:spPr>
           <a:xfrm>
-            <a:off x="7813479" y="3526971"/>
+            <a:off x="7999412" y="908958"/>
             <a:ext cx="3480665" cy="2721427"/>
           </a:xfrm>
           <a:prstGeom prst="rect">
@@ -12008,137 +12027,137 @@
           <a:lstStyle/>
           <a:p>
             <a:r>
-              <a:rPr lang="en-US" b="1"/>
+              <a:rPr lang="en-US" b="1" dirty="0"/>
               <a:t>Services </a:t>
             </a:r>
             <a:r>
-              <a:rPr lang="en-US"/>
+              <a:rPr lang="en-US" dirty="0"/>
               <a:t>(</a:t>
             </a:r>
             <a:r>
-              <a:rPr lang="en-US" err="1"/>
+              <a:rPr lang="en-US" dirty="0" err="1"/>
               <a:t>ServiceID</a:t>
             </a:r>
             <a:r>
-              <a:rPr lang="en-US"/>
+              <a:rPr lang="en-US" dirty="0"/>
               <a:t>, </a:t>
             </a:r>
             <a:r>
-              <a:rPr lang="en-US" err="1"/>
+              <a:rPr lang="en-US" dirty="0" err="1"/>
               <a:t>ServiceName</a:t>
             </a:r>
             <a:r>
-              <a:rPr lang="en-US"/>
+              <a:rPr lang="en-US" dirty="0"/>
               <a:t>, Price)</a:t>
             </a:r>
           </a:p>
           <a:p>
             <a:r>
-              <a:rPr lang="en-US" err="1"/>
+              <a:rPr lang="en-US" dirty="0" err="1"/>
               <a:t>ServiceID</a:t>
             </a:r>
             <a:r>
-              <a:rPr lang="en-US"/>
+              <a:rPr lang="en-US" dirty="0"/>
               <a:t>- Primary Key</a:t>
             </a:r>
           </a:p>
           <a:p>
-            <a:endParaRPr lang="en-US"/>
-          </a:p>
-          <a:p>
-            <a:endParaRPr lang="en-US"/>
-          </a:p>
-          <a:p>
-            <a:r>
-              <a:rPr lang="en-US" b="1" err="1"/>
+            <a:endParaRPr lang="en-US" dirty="0"/>
+          </a:p>
+          <a:p>
+            <a:endParaRPr lang="en-US" dirty="0"/>
+          </a:p>
+          <a:p>
+            <a:r>
+              <a:rPr lang="en-US" b="1" dirty="0" err="1"/>
               <a:t>BookingServices</a:t>
             </a:r>
             <a:r>
-              <a:rPr lang="en-US" b="1"/>
+              <a:rPr lang="en-US" b="1" dirty="0"/>
               <a:t> </a:t>
             </a:r>
             <a:r>
-              <a:rPr lang="en-US"/>
+              <a:rPr lang="en-US" dirty="0"/>
               <a:t>(</a:t>
             </a:r>
             <a:r>
-              <a:rPr lang="en-US" err="1"/>
+              <a:rPr lang="en-US" dirty="0" err="1"/>
               <a:t>BookingID</a:t>
             </a:r>
             <a:r>
-              <a:rPr lang="en-US"/>
+              <a:rPr lang="en-US" dirty="0"/>
               <a:t>, </a:t>
             </a:r>
             <a:r>
-              <a:rPr lang="en-US" u="sng" err="1"/>
+              <a:rPr lang="en-US" dirty="0" err="1"/>
               <a:t>ServiceID</a:t>
             </a:r>
             <a:r>
-              <a:rPr lang="en-US"/>
+              <a:rPr lang="en-US" dirty="0"/>
               <a:t>)</a:t>
             </a:r>
           </a:p>
           <a:p>
             <a:r>
-              <a:rPr lang="en-US"/>
+              <a:rPr lang="en-US" dirty="0"/>
               <a:t>	</a:t>
             </a:r>
             <a:r>
-              <a:rPr lang="en-US" err="1"/>
+              <a:rPr lang="en-US" dirty="0" err="1"/>
               <a:t>BookingID</a:t>
             </a:r>
             <a:r>
-              <a:rPr lang="en-US"/>
+              <a:rPr lang="en-US" dirty="0"/>
               <a:t> </a:t>
             </a:r>
             <a:r>
-              <a:rPr lang="en-US">
+              <a:rPr lang="en-US" dirty="0">
                 <a:sym typeface="Wingdings" panose="05000000000000000000" pitchFamily="2" charset="2"/>
               </a:rPr>
               <a:t>– Foreign Key</a:t>
             </a:r>
-            <a:endParaRPr lang="en-US"/>
-          </a:p>
-          <a:p>
-            <a:r>
-              <a:rPr lang="en-US"/>
+            <a:endParaRPr lang="en-US" dirty="0"/>
+          </a:p>
+          <a:p>
+            <a:r>
+              <a:rPr lang="en-US" dirty="0"/>
               <a:t>	</a:t>
             </a:r>
             <a:r>
-              <a:rPr lang="en-US" err="1"/>
+              <a:rPr lang="en-US" dirty="0" err="1"/>
               <a:t>ServiceID</a:t>
             </a:r>
             <a:r>
-              <a:rPr lang="en-US"/>
+              <a:rPr lang="en-US" dirty="0"/>
               <a:t> </a:t>
             </a:r>
             <a:r>
-              <a:rPr lang="en-US">
+              <a:rPr lang="en-US" dirty="0">
                 <a:sym typeface="Wingdings" panose="05000000000000000000" pitchFamily="2" charset="2"/>
               </a:rPr>
               <a:t>– Foreign Key</a:t>
             </a:r>
             <a:r>
-              <a:rPr lang="en-US"/>
+              <a:rPr lang="en-US" dirty="0"/>
               <a:t>.</a:t>
             </a:r>
           </a:p>
           <a:p>
             <a:r>
-              <a:rPr lang="en-US"/>
+              <a:rPr lang="en-US" dirty="0"/>
               <a:t>This is </a:t>
             </a:r>
             <a:r>
-              <a:rPr lang="en-US" b="1"/>
+              <a:rPr lang="en-US" b="1" dirty="0"/>
               <a:t>Many to many </a:t>
             </a:r>
             <a:r>
-              <a:rPr lang="en-US"/>
+              <a:rPr lang="en-US" dirty="0"/>
               <a:t>Bridge.</a:t>
             </a:r>
           </a:p>
           <a:p>
-            <a:endParaRPr lang="en-US"/>
+            <a:endParaRPr lang="en-US" dirty="0"/>
           </a:p>
         </p:txBody>
       </p:sp>
@@ -12800,8 +12819,12 @@
               <a:t>ServiceID</a:t>
             </a:r>
             <a:r>
+              <a:rPr lang="en-US" sz="1600"/>
+              <a:t>)- </a:t>
+            </a:r>
+            <a:r>
               <a:rPr lang="en-US" sz="1600" dirty="0"/>
-              <a:t>)- )- [</a:t>
+              <a:t>[</a:t>
             </a:r>
             <a:r>
               <a:rPr lang="en-US" sz="1600" b="1" i="1" dirty="0" err="1"/>

</xml_diff>